<commit_message>
feat: add the Insighture logo to the guidelines, templates and package
- brand/logo/: the supplied black and white logos, plus derived white-mono
  (for rose grounds, where the rose dot disappears) and black-mono (for
  single-colour print) versions.
- GUIDELINES.md: a Logo section with a usage sheet, versions per ground,
  clear space, minimum size and misuse rules.
- Every template now uses the real logo instead of a typed wordmark:
  PowerPoint layouts and footers, Word cover/headers/letterhead, PDF covers
  and running headers, email header and social cards.
- The logo SVGs ship with the package (`@insighture/design-system/logo/*`).

Co-Authored-By: Claude Opus 5.5 <noreply@anthropic.com>
</commit_message>
<xml_diff>
--- a/templates/powerpoint/Insighture-sample.pptx
+++ b/templates/powerpoint/Insighture-sample.pptx
@@ -115,13 +115,13 @@
   <p:extLst>
     <p:ext uri="{521415D9-36F7-43E2-AB2F-B90AF26B5E84}">
       <p14:sectionLst xmlns:p14="http://schemas.microsoft.com/office/powerpoint/2010/main">
-        <p14:section name="Opening" id="{7604a07a-2ada-0e4b-4326-6796184a2107}">
+        <p14:section name="Opening" id="{4f50871b-fd9c-f975-0e76-3481354caf07}">
           <p14:sldIdLst>
             <p14:sldId id="256"/>
             <p14:sldId id="257"/>
           </p14:sldIdLst>
         </p14:section>
-        <p14:section name="Body" id="{195e32bf-e23d-1039-a9ca-e04090ea694e}">
+        <p14:section name="Body" id="{516c869e-7025-2666-5cbf-1a47ae0a079c}">
           <p14:sldIdLst>
             <p14:sldId id="258"/>
             <p14:sldId id="259"/>
@@ -130,7 +130,7 @@
             <p14:sldId id="262"/>
           </p14:sldIdLst>
         </p14:section>
-        <p14:section name="Close" id="{3540c7aa-ce5e-8326-186c-5fe75bf135dd}">
+        <p14:section name="Close" id="{a63530c2-5d0c-8781-9e15-eb2c85b3d711}">
           <p14:sldIdLst>
             <p14:sldId id="263"/>
             <p14:sldId id="264"/>
@@ -1673,7 +1673,7 @@
     <p:bg>
       <p:bgPr>
         <a:blipFill dpi="0" rotWithShape="1">
-          <a:blip r:embed="rId1">
+          <a:blip r:embed="rId2">
             <a:lum/>
           </a:blip>
           <a:srcRect/>
@@ -1698,45 +1698,33 @@
           <a:chExt cx="0" cy="0"/>
         </a:xfrm>
       </p:grpSpPr>
-      <p:sp>
-        <p:nvSpPr>
-          <p:cNvPr id="2" name="Text 0"/>
-          <p:cNvSpPr/>
+      <p:pic>
+        <p:nvPicPr>
+          <p:cNvPr id="2" name="Image 0" descr="Insighture">    </p:cNvPr>
+          <p:cNvPicPr>
+            <a:picLocks noChangeAspect="1"/>
+          </p:cNvPicPr>
           <p:nvPr/>
-        </p:nvSpPr>
+        </p:nvPicPr>
+        <p:blipFill>
+          <a:blip r:embed="rId1"/>
+          <a:stretch>
+            <a:fillRect/>
+          </a:stretch>
+        </p:blipFill>
         <p:spPr>
           <a:xfrm>
             <a:off x="548640" y="502920"/>
-            <a:ext cx="3657600" cy="457200"/>
-          </a:xfrm>
-          <a:prstGeom prst="rect">
-            <a:avLst/>
-          </a:prstGeom>
-          <a:noFill/>
-          <a:ln/>
-        </p:spPr>
-        <p:txBody>
-          <a:bodyPr wrap="square" lIns="0" tIns="0" rIns="0" bIns="0" rtlCol="0" anchor="ctr"/>
-          <a:lstStyle/>
-          <a:p>
-            <a:pPr indent="0" marL="0">
-              <a:buNone/>
-            </a:pPr>
-            <a:r>
-              <a:rPr lang="en-US" sz="2200" dirty="0">
-                <a:solidFill>
-                  <a:schemeClr val="bg1"/>
-                </a:solidFill>
-              </a:rPr>
-              <a:t>Insighture</a:t>
-            </a:r>
-            <a:endParaRPr lang="en-US" sz="2200" dirty="0"/>
-          </a:p>
-        </p:txBody>
-      </p:sp>
-      <p:sp>
-        <p:nvSpPr>
-          <p:cNvPr id="3" name="Text 1"/>
+            <a:ext cx="1623060" cy="384048"/>
+          </a:xfrm>
+          <a:prstGeom prst="rect">
+            <a:avLst/>
+          </a:prstGeom>
+        </p:spPr>
+      </p:pic>
+      <p:sp>
+        <p:nvSpPr>
+          <p:cNvPr id="3" name="Text 0"/>
           <p:cNvSpPr/>
           <p:nvPr>
             <p:ph idx="101" type="title" hasCustomPrompt="1"/>
@@ -1789,7 +1777,7 @@
       </p:sp>
       <p:sp>
         <p:nvSpPr>
-          <p:cNvPr id="4" name="Text 1"/>
+          <p:cNvPr id="4" name="Text 0"/>
           <p:cNvSpPr/>
           <p:nvPr>
             <p:ph idx="102" type="body" hasCustomPrompt="1"/>
@@ -1836,7 +1824,7 @@
       </p:sp>
       <p:sp>
         <p:nvSpPr>
-          <p:cNvPr id="5" name="Text 1"/>
+          <p:cNvPr id="5" name="Text 0"/>
           <p:cNvSpPr/>
           <p:nvPr>
             <p:ph idx="103" type="body" hasCustomPrompt="1"/>
@@ -1895,7 +1883,7 @@
     <p:bg>
       <p:bgPr>
         <a:blipFill dpi="0" rotWithShape="1">
-          <a:blip r:embed="rId1">
+          <a:blip r:embed="rId2">
             <a:lum/>
           </a:blip>
           <a:srcRect/>
@@ -1920,45 +1908,33 @@
           <a:chExt cx="0" cy="0"/>
         </a:xfrm>
       </p:grpSpPr>
-      <p:sp>
-        <p:nvSpPr>
-          <p:cNvPr id="2" name="Text 0"/>
-          <p:cNvSpPr/>
+      <p:pic>
+        <p:nvPicPr>
+          <p:cNvPr id="2" name="Image 0" descr="Insighture">    </p:cNvPr>
+          <p:cNvPicPr>
+            <a:picLocks noChangeAspect="1"/>
+          </p:cNvPicPr>
           <p:nvPr/>
-        </p:nvSpPr>
-        <p:spPr>
-          <a:xfrm>
-            <a:off x="548640" y="6355080"/>
-            <a:ext cx="2743200" cy="274320"/>
-          </a:xfrm>
-          <a:prstGeom prst="rect">
-            <a:avLst/>
-          </a:prstGeom>
-          <a:noFill/>
-          <a:ln/>
-        </p:spPr>
-        <p:txBody>
-          <a:bodyPr wrap="square" lIns="0" tIns="0" rIns="0" bIns="0" rtlCol="0" anchor="ctr"/>
-          <a:lstStyle/>
-          <a:p>
-            <a:pPr indent="0" marL="0">
-              <a:buNone/>
-            </a:pPr>
-            <a:r>
-              <a:rPr lang="en-US" sz="1000" dirty="0">
-                <a:solidFill>
-                  <a:srgbClr val="A9C0C5"/>
-                </a:solidFill>
-              </a:rPr>
-              <a:t>Insighture</a:t>
-            </a:r>
-            <a:endParaRPr lang="en-US" sz="1000" dirty="0"/>
-          </a:p>
-        </p:txBody>
-      </p:sp>
-      <p:sp>
-        <p:nvSpPr>
-          <p:cNvPr id="3" name="Text 1"/>
+        </p:nvPicPr>
+        <p:blipFill>
+          <a:blip r:embed="rId1"/>
+          <a:stretch>
+            <a:fillRect/>
+          </a:stretch>
+        </p:blipFill>
+        <p:spPr>
+          <a:xfrm>
+            <a:off x="548640" y="6327648"/>
+            <a:ext cx="927463" cy="219456"/>
+          </a:xfrm>
+          <a:prstGeom prst="rect">
+            <a:avLst/>
+          </a:prstGeom>
+        </p:spPr>
+      </p:pic>
+      <p:sp>
+        <p:nvSpPr>
+          <p:cNvPr id="3" name="Text 0"/>
           <p:cNvSpPr/>
           <p:nvPr>
             <p:ph idx="101" type="body" hasCustomPrompt="1"/>
@@ -2005,7 +1981,7 @@
       </p:sp>
       <p:sp>
         <p:nvSpPr>
-          <p:cNvPr id="4" name="Text 1"/>
+          <p:cNvPr id="4" name="Text 0"/>
           <p:cNvSpPr/>
           <p:nvPr>
             <p:ph idx="102" type="title" hasCustomPrompt="1"/>
@@ -2052,7 +2028,7 @@
       </p:sp>
       <p:sp>
         <p:nvSpPr>
-          <p:cNvPr id="5" name="Text 1"/>
+          <p:cNvPr id="5" name="Text 0"/>
           <p:cNvSpPr/>
           <p:nvPr>
             <p:ph idx="103" type="body" hasCustomPrompt="1"/>
@@ -2174,45 +2150,33 @@
           <a:chExt cx="0" cy="0"/>
         </a:xfrm>
       </p:grpSpPr>
-      <p:sp>
-        <p:nvSpPr>
-          <p:cNvPr id="2" name="Text 0"/>
-          <p:cNvSpPr/>
+      <p:pic>
+        <p:nvPicPr>
+          <p:cNvPr id="2" name="Image 0" descr="Insighture">    </p:cNvPr>
+          <p:cNvPicPr>
+            <a:picLocks noChangeAspect="1"/>
+          </p:cNvPicPr>
           <p:nvPr/>
-        </p:nvSpPr>
-        <p:spPr>
-          <a:xfrm>
-            <a:off x="548640" y="6355080"/>
-            <a:ext cx="2743200" cy="274320"/>
-          </a:xfrm>
-          <a:prstGeom prst="rect">
-            <a:avLst/>
-          </a:prstGeom>
-          <a:noFill/>
-          <a:ln/>
-        </p:spPr>
-        <p:txBody>
-          <a:bodyPr wrap="square" lIns="0" tIns="0" rIns="0" bIns="0" rtlCol="0" anchor="ctr"/>
-          <a:lstStyle/>
-          <a:p>
-            <a:pPr indent="0" marL="0">
-              <a:buNone/>
-            </a:pPr>
-            <a:r>
-              <a:rPr lang="en-US" sz="1000" dirty="0">
-                <a:solidFill>
-                  <a:srgbClr val="6B7278"/>
-                </a:solidFill>
-              </a:rPr>
-              <a:t>Insighture</a:t>
-            </a:r>
-            <a:endParaRPr lang="en-US" sz="1000" dirty="0"/>
-          </a:p>
-        </p:txBody>
-      </p:sp>
-      <p:sp>
-        <p:nvSpPr>
-          <p:cNvPr id="3" name="Text 1"/>
+        </p:nvPicPr>
+        <p:blipFill>
+          <a:blip r:embed="rId1"/>
+          <a:stretch>
+            <a:fillRect/>
+          </a:stretch>
+        </p:blipFill>
+        <p:spPr>
+          <a:xfrm>
+            <a:off x="548640" y="6327648"/>
+            <a:ext cx="927463" cy="219456"/>
+          </a:xfrm>
+          <a:prstGeom prst="rect">
+            <a:avLst/>
+          </a:prstGeom>
+        </p:spPr>
+      </p:pic>
+      <p:sp>
+        <p:nvSpPr>
+          <p:cNvPr id="3" name="Text 0"/>
           <p:cNvSpPr/>
           <p:nvPr>
             <p:ph idx="101" type="body" hasCustomPrompt="1"/>
@@ -2259,7 +2223,7 @@
       </p:sp>
       <p:sp>
         <p:nvSpPr>
-          <p:cNvPr id="4" name="Text 1"/>
+          <p:cNvPr id="4" name="Text 0"/>
           <p:cNvSpPr/>
           <p:nvPr>
             <p:ph idx="102" type="title" hasCustomPrompt="1"/>
@@ -2306,7 +2270,7 @@
       </p:sp>
       <p:sp>
         <p:nvSpPr>
-          <p:cNvPr id="5" name="Text 1"/>
+          <p:cNvPr id="5" name="Text 0"/>
           <p:cNvSpPr/>
           <p:nvPr>
             <p:ph idx="103" type="body" hasCustomPrompt="1"/>
@@ -2434,45 +2398,33 @@
           <a:chExt cx="0" cy="0"/>
         </a:xfrm>
       </p:grpSpPr>
-      <p:sp>
-        <p:nvSpPr>
-          <p:cNvPr id="2" name="Text 0"/>
-          <p:cNvSpPr/>
+      <p:pic>
+        <p:nvPicPr>
+          <p:cNvPr id="2" name="Image 0" descr="Insighture">    </p:cNvPr>
+          <p:cNvPicPr>
+            <a:picLocks noChangeAspect="1"/>
+          </p:cNvPicPr>
           <p:nvPr/>
-        </p:nvSpPr>
-        <p:spPr>
-          <a:xfrm>
-            <a:off x="548640" y="6355080"/>
-            <a:ext cx="2743200" cy="274320"/>
-          </a:xfrm>
-          <a:prstGeom prst="rect">
-            <a:avLst/>
-          </a:prstGeom>
-          <a:noFill/>
-          <a:ln/>
-        </p:spPr>
-        <p:txBody>
-          <a:bodyPr wrap="square" lIns="0" tIns="0" rIns="0" bIns="0" rtlCol="0" anchor="ctr"/>
-          <a:lstStyle/>
-          <a:p>
-            <a:pPr indent="0" marL="0">
-              <a:buNone/>
-            </a:pPr>
-            <a:r>
-              <a:rPr lang="en-US" sz="1000" dirty="0">
-                <a:solidFill>
-                  <a:srgbClr val="6B7278"/>
-                </a:solidFill>
-              </a:rPr>
-              <a:t>Insighture</a:t>
-            </a:r>
-            <a:endParaRPr lang="en-US" sz="1000" dirty="0"/>
-          </a:p>
-        </p:txBody>
-      </p:sp>
-      <p:sp>
-        <p:nvSpPr>
-          <p:cNvPr id="3" name="Text 1"/>
+        </p:nvPicPr>
+        <p:blipFill>
+          <a:blip r:embed="rId1"/>
+          <a:stretch>
+            <a:fillRect/>
+          </a:stretch>
+        </p:blipFill>
+        <p:spPr>
+          <a:xfrm>
+            <a:off x="548640" y="6327648"/>
+            <a:ext cx="927463" cy="219456"/>
+          </a:xfrm>
+          <a:prstGeom prst="rect">
+            <a:avLst/>
+          </a:prstGeom>
+        </p:spPr>
+      </p:pic>
+      <p:sp>
+        <p:nvSpPr>
+          <p:cNvPr id="3" name="Text 0"/>
           <p:cNvSpPr/>
           <p:nvPr>
             <p:ph idx="101" type="body" hasCustomPrompt="1"/>
@@ -2519,7 +2471,7 @@
       </p:sp>
       <p:sp>
         <p:nvSpPr>
-          <p:cNvPr id="4" name="Text 1"/>
+          <p:cNvPr id="4" name="Text 0"/>
           <p:cNvSpPr/>
           <p:nvPr>
             <p:ph idx="102" type="title" hasCustomPrompt="1"/>
@@ -2566,7 +2518,7 @@
       </p:sp>
       <p:sp>
         <p:nvSpPr>
-          <p:cNvPr id="5" name="Text 1"/>
+          <p:cNvPr id="5" name="Text 0"/>
           <p:cNvSpPr/>
           <p:nvPr>
             <p:ph idx="103" type="body" hasCustomPrompt="1"/>
@@ -2619,7 +2571,7 @@
       </p:sp>
       <p:sp>
         <p:nvSpPr>
-          <p:cNvPr id="6" name="Text 1"/>
+          <p:cNvPr id="6" name="Text 0"/>
           <p:cNvSpPr/>
           <p:nvPr>
             <p:ph idx="104" type="body" hasCustomPrompt="1"/>
@@ -2747,45 +2699,33 @@
           <a:chExt cx="0" cy="0"/>
         </a:xfrm>
       </p:grpSpPr>
-      <p:sp>
-        <p:nvSpPr>
-          <p:cNvPr id="2" name="Text 0"/>
-          <p:cNvSpPr/>
+      <p:pic>
+        <p:nvPicPr>
+          <p:cNvPr id="2" name="Image 0" descr="Insighture">    </p:cNvPr>
+          <p:cNvPicPr>
+            <a:picLocks noChangeAspect="1"/>
+          </p:cNvPicPr>
           <p:nvPr/>
-        </p:nvSpPr>
-        <p:spPr>
-          <a:xfrm>
-            <a:off x="548640" y="6355080"/>
-            <a:ext cx="2743200" cy="274320"/>
-          </a:xfrm>
-          <a:prstGeom prst="rect">
-            <a:avLst/>
-          </a:prstGeom>
-          <a:noFill/>
-          <a:ln/>
-        </p:spPr>
-        <p:txBody>
-          <a:bodyPr wrap="square" lIns="0" tIns="0" rIns="0" bIns="0" rtlCol="0" anchor="ctr"/>
-          <a:lstStyle/>
-          <a:p>
-            <a:pPr indent="0" marL="0">
-              <a:buNone/>
-            </a:pPr>
-            <a:r>
-              <a:rPr lang="en-US" sz="1000" dirty="0">
-                <a:solidFill>
-                  <a:srgbClr val="6B7278"/>
-                </a:solidFill>
-              </a:rPr>
-              <a:t>Insighture</a:t>
-            </a:r>
-            <a:endParaRPr lang="en-US" sz="1000" dirty="0"/>
-          </a:p>
-        </p:txBody>
-      </p:sp>
-      <p:sp>
-        <p:nvSpPr>
-          <p:cNvPr id="3" name="Text 1"/>
+        </p:nvPicPr>
+        <p:blipFill>
+          <a:blip r:embed="rId1"/>
+          <a:stretch>
+            <a:fillRect/>
+          </a:stretch>
+        </p:blipFill>
+        <p:spPr>
+          <a:xfrm>
+            <a:off x="548640" y="6327648"/>
+            <a:ext cx="927463" cy="219456"/>
+          </a:xfrm>
+          <a:prstGeom prst="rect">
+            <a:avLst/>
+          </a:prstGeom>
+        </p:spPr>
+      </p:pic>
+      <p:sp>
+        <p:nvSpPr>
+          <p:cNvPr id="3" name="Text 0"/>
           <p:cNvSpPr/>
           <p:nvPr>
             <p:ph idx="101" type="body" hasCustomPrompt="1"/>
@@ -2832,7 +2772,7 @@
       </p:sp>
       <p:sp>
         <p:nvSpPr>
-          <p:cNvPr id="4" name="Text 1"/>
+          <p:cNvPr id="4" name="Text 0"/>
           <p:cNvSpPr/>
           <p:nvPr>
             <p:ph idx="102" type="title" hasCustomPrompt="1"/>
@@ -2954,45 +2894,33 @@
           <a:chExt cx="0" cy="0"/>
         </a:xfrm>
       </p:grpSpPr>
-      <p:sp>
-        <p:nvSpPr>
-          <p:cNvPr id="2" name="Text 0"/>
-          <p:cNvSpPr/>
+      <p:pic>
+        <p:nvPicPr>
+          <p:cNvPr id="2" name="Image 0" descr="Insighture">    </p:cNvPr>
+          <p:cNvPicPr>
+            <a:picLocks noChangeAspect="1"/>
+          </p:cNvPicPr>
           <p:nvPr/>
-        </p:nvSpPr>
-        <p:spPr>
-          <a:xfrm>
-            <a:off x="548640" y="6355080"/>
-            <a:ext cx="2743200" cy="274320"/>
-          </a:xfrm>
-          <a:prstGeom prst="rect">
-            <a:avLst/>
-          </a:prstGeom>
-          <a:noFill/>
-          <a:ln/>
-        </p:spPr>
-        <p:txBody>
-          <a:bodyPr wrap="square" lIns="0" tIns="0" rIns="0" bIns="0" rtlCol="0" anchor="ctr"/>
-          <a:lstStyle/>
-          <a:p>
-            <a:pPr indent="0" marL="0">
-              <a:buNone/>
-            </a:pPr>
-            <a:r>
-              <a:rPr lang="en-US" sz="1000" dirty="0">
-                <a:solidFill>
-                  <a:srgbClr val="6B7278"/>
-                </a:solidFill>
-              </a:rPr>
-              <a:t>Insighture</a:t>
-            </a:r>
-            <a:endParaRPr lang="en-US" sz="1000" dirty="0"/>
-          </a:p>
-        </p:txBody>
-      </p:sp>
-      <p:sp>
-        <p:nvSpPr>
-          <p:cNvPr id="3" name="Text 1"/>
+        </p:nvPicPr>
+        <p:blipFill>
+          <a:blip r:embed="rId1"/>
+          <a:stretch>
+            <a:fillRect/>
+          </a:stretch>
+        </p:blipFill>
+        <p:spPr>
+          <a:xfrm>
+            <a:off x="548640" y="6327648"/>
+            <a:ext cx="927463" cy="219456"/>
+          </a:xfrm>
+          <a:prstGeom prst="rect">
+            <a:avLst/>
+          </a:prstGeom>
+        </p:spPr>
+      </p:pic>
+      <p:sp>
+        <p:nvSpPr>
+          <p:cNvPr id="3" name="Text 0"/>
           <p:cNvSpPr/>
           <p:nvPr>
             <p:ph idx="101" type="body" hasCustomPrompt="1"/>
@@ -3039,7 +2967,7 @@
       </p:sp>
       <p:sp>
         <p:nvSpPr>
-          <p:cNvPr id="4" name="Text 1"/>
+          <p:cNvPr id="4" name="Text 0"/>
           <p:cNvSpPr/>
           <p:nvPr>
             <p:ph idx="102" type="body" hasCustomPrompt="1"/>
@@ -3086,7 +3014,7 @@
       </p:sp>
       <p:sp>
         <p:nvSpPr>
-          <p:cNvPr id="5" name="Text 1"/>
+          <p:cNvPr id="5" name="Text 0"/>
           <p:cNvSpPr/>
           <p:nvPr>
             <p:ph idx="103" type="body" hasCustomPrompt="1"/>
@@ -3133,7 +3061,7 @@
       </p:sp>
       <p:sp>
         <p:nvSpPr>
-          <p:cNvPr id="6" name="Text 1"/>
+          <p:cNvPr id="6" name="Text 0"/>
           <p:cNvSpPr/>
           <p:nvPr>
             <p:ph idx="104" type="body" hasCustomPrompt="1"/>
@@ -3237,7 +3165,7 @@
     <p:bg>
       <p:bgPr>
         <a:blipFill dpi="0" rotWithShape="1">
-          <a:blip r:embed="rId1">
+          <a:blip r:embed="rId2">
             <a:lum/>
           </a:blip>
           <a:srcRect/>
@@ -3262,45 +3190,33 @@
           <a:chExt cx="0" cy="0"/>
         </a:xfrm>
       </p:grpSpPr>
-      <p:sp>
-        <p:nvSpPr>
-          <p:cNvPr id="2" name="Text 0"/>
-          <p:cNvSpPr/>
+      <p:pic>
+        <p:nvPicPr>
+          <p:cNvPr id="2" name="Image 0" descr="Insighture">    </p:cNvPr>
+          <p:cNvPicPr>
+            <a:picLocks noChangeAspect="1"/>
+          </p:cNvPicPr>
           <p:nvPr/>
-        </p:nvSpPr>
-        <p:spPr>
-          <a:xfrm>
-            <a:off x="548640" y="6355080"/>
-            <a:ext cx="2743200" cy="274320"/>
-          </a:xfrm>
-          <a:prstGeom prst="rect">
-            <a:avLst/>
-          </a:prstGeom>
-          <a:noFill/>
-          <a:ln/>
-        </p:spPr>
-        <p:txBody>
-          <a:bodyPr wrap="square" lIns="0" tIns="0" rIns="0" bIns="0" rtlCol="0" anchor="ctr"/>
-          <a:lstStyle/>
-          <a:p>
-            <a:pPr indent="0" marL="0">
-              <a:buNone/>
-            </a:pPr>
-            <a:r>
-              <a:rPr lang="en-US" sz="1000" dirty="0">
-                <a:solidFill>
-                  <a:srgbClr val="A9C0C5"/>
-                </a:solidFill>
-              </a:rPr>
-              <a:t>Insighture</a:t>
-            </a:r>
-            <a:endParaRPr lang="en-US" sz="1000" dirty="0"/>
-          </a:p>
-        </p:txBody>
-      </p:sp>
-      <p:sp>
-        <p:nvSpPr>
-          <p:cNvPr id="3" name="Text 1"/>
+        </p:nvPicPr>
+        <p:blipFill>
+          <a:blip r:embed="rId1"/>
+          <a:stretch>
+            <a:fillRect/>
+          </a:stretch>
+        </p:blipFill>
+        <p:spPr>
+          <a:xfrm>
+            <a:off x="548640" y="6327648"/>
+            <a:ext cx="927463" cy="219456"/>
+          </a:xfrm>
+          <a:prstGeom prst="rect">
+            <a:avLst/>
+          </a:prstGeom>
+        </p:spPr>
+      </p:pic>
+      <p:sp>
+        <p:nvSpPr>
+          <p:cNvPr id="3" name="Text 0"/>
           <p:cNvSpPr/>
           <p:nvPr/>
         </p:nvSpPr>
@@ -3339,7 +3255,7 @@
       </p:sp>
       <p:sp>
         <p:nvSpPr>
-          <p:cNvPr id="4" name="Text 2"/>
+          <p:cNvPr id="4" name="Text 1"/>
           <p:cNvSpPr/>
           <p:nvPr>
             <p:ph idx="102" type="body" hasCustomPrompt="1"/>
@@ -3392,7 +3308,7 @@
       </p:sp>
       <p:sp>
         <p:nvSpPr>
-          <p:cNvPr id="5" name="Text 2"/>
+          <p:cNvPr id="5" name="Text 1"/>
           <p:cNvSpPr/>
           <p:nvPr>
             <p:ph idx="103" type="body" hasCustomPrompt="1"/>
@@ -3439,7 +3355,7 @@
       </p:sp>
       <p:sp>
         <p:nvSpPr>
-          <p:cNvPr id="6" name="Text 2"/>
+          <p:cNvPr id="6" name="Text 1"/>
           <p:cNvSpPr/>
           <p:nvPr>
             <p:ph idx="104" type="body" hasCustomPrompt="1"/>
@@ -3543,7 +3459,7 @@
     <p:bg>
       <p:bgPr>
         <a:blipFill dpi="0" rotWithShape="1">
-          <a:blip r:embed="rId1">
+          <a:blip r:embed="rId2">
             <a:lum/>
           </a:blip>
           <a:srcRect/>
@@ -3568,45 +3484,33 @@
           <a:chExt cx="0" cy="0"/>
         </a:xfrm>
       </p:grpSpPr>
-      <p:sp>
-        <p:nvSpPr>
-          <p:cNvPr id="2" name="Text 0"/>
-          <p:cNvSpPr/>
+      <p:pic>
+        <p:nvPicPr>
+          <p:cNvPr id="2" name="Image 0" descr="Insighture">    </p:cNvPr>
+          <p:cNvPicPr>
+            <a:picLocks noChangeAspect="1"/>
+          </p:cNvPicPr>
           <p:nvPr/>
-        </p:nvSpPr>
+        </p:nvPicPr>
+        <p:blipFill>
+          <a:blip r:embed="rId1"/>
+          <a:stretch>
+            <a:fillRect/>
+          </a:stretch>
+        </p:blipFill>
         <p:spPr>
           <a:xfrm>
             <a:off x="548640" y="502920"/>
-            <a:ext cx="3657600" cy="457200"/>
-          </a:xfrm>
-          <a:prstGeom prst="rect">
-            <a:avLst/>
-          </a:prstGeom>
-          <a:noFill/>
-          <a:ln/>
-        </p:spPr>
-        <p:txBody>
-          <a:bodyPr wrap="square" lIns="0" tIns="0" rIns="0" bIns="0" rtlCol="0" anchor="ctr"/>
-          <a:lstStyle/>
-          <a:p>
-            <a:pPr indent="0" marL="0">
-              <a:buNone/>
-            </a:pPr>
-            <a:r>
-              <a:rPr lang="en-US" sz="2200" dirty="0">
-                <a:solidFill>
-                  <a:schemeClr val="bg1"/>
-                </a:solidFill>
-              </a:rPr>
-              <a:t>Insighture</a:t>
-            </a:r>
-            <a:endParaRPr lang="en-US" sz="2200" dirty="0"/>
-          </a:p>
-        </p:txBody>
-      </p:sp>
-      <p:sp>
-        <p:nvSpPr>
-          <p:cNvPr id="3" name="Text 1"/>
+            <a:ext cx="1623060" cy="384048"/>
+          </a:xfrm>
+          <a:prstGeom prst="rect">
+            <a:avLst/>
+          </a:prstGeom>
+        </p:spPr>
+      </p:pic>
+      <p:sp>
+        <p:nvSpPr>
+          <p:cNvPr id="3" name="Text 0"/>
           <p:cNvSpPr/>
           <p:nvPr>
             <p:ph idx="101" type="title" hasCustomPrompt="1"/>
@@ -3653,7 +3557,7 @@
       </p:sp>
       <p:sp>
         <p:nvSpPr>
-          <p:cNvPr id="4" name="Text 1"/>
+          <p:cNvPr id="4" name="Text 0"/>
           <p:cNvSpPr/>
           <p:nvPr>
             <p:ph idx="102" type="body" hasCustomPrompt="1"/>
@@ -4061,7 +3965,7 @@
       </p:grpSpPr>
       <p:sp>
         <p:nvSpPr>
-          <p:cNvPr id="2" name="Text 1"/>
+          <p:cNvPr id="2" name="Text 0"/>
           <p:cNvSpPr/>
           <p:nvPr>
             <p:ph idx="101" type="title" hasCustomPrompt="1"/>
@@ -4113,7 +4017,7 @@
       </p:sp>
       <p:sp>
         <p:nvSpPr>
-          <p:cNvPr id="3" name="Text 1"/>
+          <p:cNvPr id="3" name="Text 0"/>
           <p:cNvSpPr/>
           <p:nvPr>
             <p:ph idx="102" type="body" hasCustomPrompt="1"/>
@@ -4151,7 +4055,7 @@
       </p:sp>
       <p:sp>
         <p:nvSpPr>
-          <p:cNvPr id="4" name="Text 1"/>
+          <p:cNvPr id="4" name="Text 0"/>
           <p:cNvSpPr/>
           <p:nvPr>
             <p:ph idx="103" type="body" hasCustomPrompt="1"/>
@@ -4214,7 +4118,7 @@
       </p:grpSpPr>
       <p:sp>
         <p:nvSpPr>
-          <p:cNvPr id="2" name="Text 1"/>
+          <p:cNvPr id="2" name="Text 0"/>
           <p:cNvSpPr/>
           <p:nvPr>
             <p:ph idx="101" type="body" hasCustomPrompt="1"/>
@@ -4252,7 +4156,7 @@
       </p:sp>
       <p:sp>
         <p:nvSpPr>
-          <p:cNvPr id="3" name="Text 1"/>
+          <p:cNvPr id="3" name="Text 0"/>
           <p:cNvSpPr/>
           <p:nvPr>
             <p:ph idx="102" type="title" hasCustomPrompt="1"/>
@@ -5028,7 +4932,7 @@
       </p:grpSpPr>
       <p:sp>
         <p:nvSpPr>
-          <p:cNvPr id="2" name="Text 1"/>
+          <p:cNvPr id="2" name="Text 0"/>
           <p:cNvSpPr/>
           <p:nvPr>
             <p:ph idx="101" type="body" hasCustomPrompt="1"/>
@@ -5066,7 +4970,7 @@
       </p:sp>
       <p:sp>
         <p:nvSpPr>
-          <p:cNvPr id="3" name="Text 1"/>
+          <p:cNvPr id="3" name="Text 0"/>
           <p:cNvSpPr/>
           <p:nvPr>
             <p:ph idx="102" type="title" hasCustomPrompt="1"/>
@@ -5115,7 +5019,7 @@
       </p:sp>
       <p:sp>
         <p:nvSpPr>
-          <p:cNvPr id="4" name="Text 1"/>
+          <p:cNvPr id="4" name="Text 0"/>
           <p:cNvSpPr/>
           <p:nvPr>
             <p:ph idx="103" type="body" hasCustomPrompt="1"/>
@@ -5223,7 +5127,7 @@
       </p:grpSpPr>
       <p:sp>
         <p:nvSpPr>
-          <p:cNvPr id="2" name="Text 1"/>
+          <p:cNvPr id="2" name="Text 0"/>
           <p:cNvSpPr/>
           <p:nvPr>
             <p:ph idx="101" type="body" hasCustomPrompt="1"/>
@@ -5261,7 +5165,7 @@
       </p:sp>
       <p:sp>
         <p:nvSpPr>
-          <p:cNvPr id="3" name="Text 1"/>
+          <p:cNvPr id="3" name="Text 0"/>
           <p:cNvSpPr/>
           <p:nvPr>
             <p:ph idx="102" type="title" hasCustomPrompt="1"/>
@@ -6188,7 +6092,7 @@
       </p:grpSpPr>
       <p:sp>
         <p:nvSpPr>
-          <p:cNvPr id="2" name="Text 1"/>
+          <p:cNvPr id="2" name="Text 0"/>
           <p:cNvSpPr/>
           <p:nvPr>
             <p:ph idx="101" type="body" hasCustomPrompt="1"/>
@@ -6226,7 +6130,7 @@
       </p:sp>
       <p:sp>
         <p:nvSpPr>
-          <p:cNvPr id="3" name="Text 1"/>
+          <p:cNvPr id="3" name="Text 0"/>
           <p:cNvSpPr/>
           <p:nvPr>
             <p:ph idx="102" type="body" hasCustomPrompt="1"/>
@@ -6264,7 +6168,7 @@
       </p:sp>
       <p:sp>
         <p:nvSpPr>
-          <p:cNvPr id="4" name="Text 1"/>
+          <p:cNvPr id="4" name="Text 0"/>
           <p:cNvSpPr/>
           <p:nvPr>
             <p:ph idx="103" type="body" hasCustomPrompt="1"/>
@@ -6302,7 +6206,7 @@
       </p:sp>
       <p:sp>
         <p:nvSpPr>
-          <p:cNvPr id="5" name="Text 1"/>
+          <p:cNvPr id="5" name="Text 0"/>
           <p:cNvSpPr/>
           <p:nvPr>
             <p:ph idx="104" type="body" hasCustomPrompt="1"/>
@@ -6648,7 +6552,7 @@
       </p:grpSpPr>
       <p:sp>
         <p:nvSpPr>
-          <p:cNvPr id="2" name="Text 1"/>
+          <p:cNvPr id="2" name="Text 0"/>
           <p:cNvSpPr/>
           <p:nvPr>
             <p:ph idx="101" type="body" hasCustomPrompt="1"/>
@@ -6686,7 +6590,7 @@
       </p:sp>
       <p:sp>
         <p:nvSpPr>
-          <p:cNvPr id="3" name="Text 1"/>
+          <p:cNvPr id="3" name="Text 0"/>
           <p:cNvSpPr/>
           <p:nvPr>
             <p:ph idx="102" type="title" hasCustomPrompt="1"/>
@@ -6921,7 +6825,7 @@
       </p:sp>
       <p:sp>
         <p:nvSpPr>
-          <p:cNvPr id="4" name="Text 1"/>
+          <p:cNvPr id="4" name="Text 0"/>
           <p:cNvSpPr/>
           <p:nvPr>
             <p:ph idx="101" type="body" hasCustomPrompt="1"/>
@@ -6959,7 +6863,7 @@
       </p:sp>
       <p:sp>
         <p:nvSpPr>
-          <p:cNvPr id="5" name="Text 1"/>
+          <p:cNvPr id="5" name="Text 0"/>
           <p:cNvSpPr/>
           <p:nvPr>
             <p:ph idx="102" type="title" hasCustomPrompt="1"/>
@@ -6997,7 +6901,7 @@
       </p:sp>
       <p:sp>
         <p:nvSpPr>
-          <p:cNvPr id="6" name="Text 1"/>
+          <p:cNvPr id="6" name="Text 0"/>
           <p:cNvSpPr/>
           <p:nvPr>
             <p:ph idx="103" type="body" hasCustomPrompt="1"/>
@@ -7092,7 +6996,7 @@
       </p:sp>
       <p:sp>
         <p:nvSpPr>
-          <p:cNvPr id="7" name="Text 1"/>
+          <p:cNvPr id="7" name="Text 0"/>
           <p:cNvSpPr/>
           <p:nvPr>
             <p:ph idx="104" type="body" hasCustomPrompt="1"/>
@@ -7257,7 +7161,7 @@
       </p:grpSpPr>
       <p:sp>
         <p:nvSpPr>
-          <p:cNvPr id="2" name="Text 2"/>
+          <p:cNvPr id="2" name="Text 1"/>
           <p:cNvSpPr/>
           <p:nvPr>
             <p:ph idx="102" type="body" hasCustomPrompt="1"/>
@@ -7298,7 +7202,7 @@
       </p:sp>
       <p:sp>
         <p:nvSpPr>
-          <p:cNvPr id="3" name="Text 2"/>
+          <p:cNvPr id="3" name="Text 1"/>
           <p:cNvSpPr/>
           <p:nvPr>
             <p:ph idx="103" type="body" hasCustomPrompt="1"/>
@@ -7336,7 +7240,7 @@
       </p:sp>
       <p:sp>
         <p:nvSpPr>
-          <p:cNvPr id="4" name="Text 2"/>
+          <p:cNvPr id="4" name="Text 1"/>
           <p:cNvSpPr/>
           <p:nvPr>
             <p:ph idx="104" type="body" hasCustomPrompt="1"/>
@@ -7444,7 +7348,7 @@
       </p:grpSpPr>
       <p:sp>
         <p:nvSpPr>
-          <p:cNvPr id="2" name="Text 1"/>
+          <p:cNvPr id="2" name="Text 0"/>
           <p:cNvSpPr/>
           <p:nvPr>
             <p:ph idx="101" type="title" hasCustomPrompt="1"/>
@@ -7493,7 +7397,7 @@
       </p:sp>
       <p:sp>
         <p:nvSpPr>
-          <p:cNvPr id="3" name="Text 1"/>
+          <p:cNvPr id="3" name="Text 0"/>
           <p:cNvSpPr/>
           <p:nvPr>
             <p:ph idx="102" type="body" hasCustomPrompt="1"/>

</xml_diff>

<commit_message>
feat: brand kit for AI assistants, with a brand checker
skills/insighture-design-system/ packages the brand for any AI tool:
SKILL.md for Claude and other Agent Skills readers, a generated AGENTS.md
for Codex, Cursor, Copilot, Gemini and custom GPTs/Gems, the logo, the
Office and email templates, and the tokens. `npm run skill` rebuilds it
and zips it to dist/ for upload.

scripts/check_brand.py (Python 3, no dependencies) checks .pptx, .docx,
.xlsx, .html, .css, .svg and .pdf files for off-palette colours, non-brand
fonts, a missing logo and overuse of rose, and exits non-zero on errors.

Running it over the templates found Office defaults leaking through, now
fixed in the generators: the chart's hidden value axis kept pptxgenjs'
grey/black/Arial, Word's Heading 4-6 and Hyperlink styles were Office
blue, and the card-grid slide had a second rose element.

Co-Authored-By: Claude Opus 5.5 <noreply@anthropic.com>
</commit_message>
<xml_diff>
--- a/templates/powerpoint/Insighture-sample.pptx
+++ b/templates/powerpoint/Insighture-sample.pptx
@@ -115,13 +115,13 @@
   <p:extLst>
     <p:ext uri="{521415D9-36F7-43E2-AB2F-B90AF26B5E84}">
       <p14:sectionLst xmlns:p14="http://schemas.microsoft.com/office/powerpoint/2010/main">
-        <p14:section name="Opening" id="{4f50871b-fd9c-f975-0e76-3481354caf07}">
+        <p14:section name="Opening" id="{efb57cfa-948b-2cf2-7b09-1a9c89f54b4b}">
           <p14:sldIdLst>
             <p14:sldId id="256"/>
             <p14:sldId id="257"/>
           </p14:sldIdLst>
         </p14:section>
-        <p14:section name="Body" id="{516c869e-7025-2666-5cbf-1a47ae0a079c}">
+        <p14:section name="Body" id="{fe6d78fa-604d-afe5-aeb2-71424b2971ae}">
           <p14:sldIdLst>
             <p14:sldId id="258"/>
             <p14:sldId id="259"/>
@@ -130,7 +130,7 @@
             <p14:sldId id="262"/>
           </p14:sldIdLst>
         </p14:section>
-        <p14:section name="Close" id="{a63530c2-5d0c-8781-9e15-eb2c85b3d711}">
+        <p14:section name="Close" id="{e6d1fe25-8ff0-fad3-3912-be05da9ceb59}">
           <p14:sldIdLst>
             <p14:sldId id="263"/>
             <p14:sldId id="264"/>
@@ -446,9 +446,7 @@
         <c:tickLblPos val="nextTo"/>
         <c:spPr>
           <a:ln w="12700" cap="flat">
-            <a:solidFill>
-              <a:srgbClr val="888888"/>
-            </a:solidFill>
+            <a:noFill/>
             <a:prstDash val="solid"/>
             <a:round/>
           </a:ln>
@@ -460,9 +458,9 @@
             <a:pPr>
               <a:defRPr sz="1200" b="0" i="0" u="none" strike="noStrike">
                 <a:solidFill>
-                  <a:srgbClr val="000000"/>
-                </a:solidFill>
-                <a:latin typeface="Arial"/>
+                  <a:srgbClr val="6B7278"/>
+                </a:solidFill>
+                <a:latin typeface="+mn-lt"/>
               </a:defRPr>
             </a:pPr>
             <a:endParaRPr lang="en-US"/>
@@ -5263,7 +5261,7 @@
             </a:avLst>
           </a:prstGeom>
           <a:solidFill>
-            <a:schemeClr val="accent1">
+            <a:schemeClr val="accent5">
               <a:alpha val="18000"/>
             </a:schemeClr>
           </a:solidFill>
@@ -5297,7 +5295,7 @@
             <a:r>
               <a:rPr lang="en-US" sz="1500" b="1" dirty="0">
                 <a:solidFill>
-                  <a:srgbClr val="B11032"/>
+                  <a:srgbClr val="2018A8"/>
                 </a:solidFill>
               </a:rPr>
               <a:t>AI</a:t>
@@ -5405,7 +5403,7 @@
             <a:r>
               <a:rPr lang="en-US" sz="1400" dirty="0">
                 <a:solidFill>
-                  <a:srgbClr val="B11032"/>
+                  <a:srgbClr val="2018A8"/>
                 </a:solidFill>
               </a:rPr>
               <a:t>Learn more  ›</a:t>

</xml_diff>